<commit_message>
Move experiments out of submission
</commit_message>
<xml_diff>
--- a/presentation/accentedness-scoring-challenge.pptx
+++ b/presentation/accentedness-scoring-challenge.pptx
@@ -6879,7 +6879,7 @@
                 </a:solidFill>
                 <a:latin typeface="Avenir Next"/>
               </a:rPr>
-              <a:t>Sources: experiments/E09–E13; submission/docs/GOPT_PILOT_RESULTS.md</a:t>
+              <a:t>Sources: experiments/E09–E13; E11/GOPT_PILOT_RESULTS.md</a:t>
             </a:r>
           </a:p>
         </p:txBody>
@@ -24177,7 +24177,7 @@
                 </a:solidFill>
                 <a:latin typeface="Avenir Next"/>
               </a:rPr>
-              <a:t>Sources: submission/docs/SNIFF_TEST.md; experiments/E07 and E08</a:t>
+              <a:t>Sources: experiments/E07-sniff-tests/SNIFF_TEST.md; E07 and E08</a:t>
             </a:r>
           </a:p>
         </p:txBody>

</xml_diff>

<commit_message>
Promote E16 and add Colab experiment workflows
</commit_message>
<xml_diff>
--- a/presentation/accentedness-scoring-challenge.pptx
+++ b/presentation/accentedness-scoring-challenge.pptx
@@ -10627,7 +10627,7 @@
                 </a:solidFill>
                 <a:latin typeface="Avenir Next"/>
               </a:rPr>
-              <a:t>Ship today</a:t>
+              <a:t>Current scope</a:t>
             </a:r>
           </a:p>
         </p:txBody>
@@ -10669,7 +10669,7 @@
                 </a:solidFill>
                 <a:latin typeface="Avenir Next"/>
               </a:rPr>
-              <a:t>A coaching prototype with visible uncertainty—not a high-stakes judgment of identity, ability, or proficiency.</a:t>
+              <a:t>A local coaching prototype with visible uncertainty—not a high-stakes judgment of identity, ability, or proficiency.</a:t>
             </a:r>
           </a:p>
         </p:txBody>
@@ -16347,7 +16347,7 @@
                 </a:solidFill>
                 <a:latin typeface="Avenir Next"/>
               </a:rPr>
-              <a:t>Training discipline: tune epochs on train-only development data, then restart and fit all 2,799 training utterances.</a:t>
+              <a:t>Training discipline: select the objective with prompt-purged grouped OOF, then run one fixed fit on all 2,799 training utterances.</a:t>
             </a:r>
           </a:p>
         </p:txBody>
@@ -16424,7 +16424,7 @@
                 </a:solidFill>
                 <a:latin typeface="Avenir Next"/>
               </a:rPr>
-              <a:t>Sources: submission/WRITEUP.md; experiments/E01-production-model/README.md</a:t>
+              <a:t>Sources: submission/WRITEUP.md; experiments/E16-alpha054-confirmation/README.md</a:t>
             </a:r>
           </a:p>
         </p:txBody>
@@ -18176,7 +18176,7 @@
                 </a:solidFill>
                 <a:latin typeface="Avenir Next"/>
               </a:rPr>
-              <a:t>Loss weighting: inverse √ class frequency per phone token</a:t>
+              <a:t>Loss weighting: n_c⁻⁰·⁵⁴ per token • mean-one normalized</a:t>
             </a:r>
           </a:p>
         </p:txBody>
@@ -18405,7 +18405,7 @@
                 </a:solidFill>
                 <a:latin typeface="Avenir Next"/>
               </a:rPr>
-              <a:t>Validation: audio adds material signal</a:t>
+              <a:t>Validation: E16 improves balanced error</a:t>
             </a:r>
           </a:p>
         </p:txBody>
@@ -18566,7 +18566,7 @@
                 </a:solidFill>
                 <a:latin typeface="Avenir Next"/>
               </a:rPr>
-              <a:t>Always 100</a:t>
+              <a:t>Strongest static</a:t>
             </a:r>
           </a:p>
         </p:txBody>
@@ -18623,13 +18623,13 @@
         <p:spPr>
           <a:xfrm>
             <a:off x="1993392" y="2240280"/>
-            <a:ext cx="3749039" cy="420624"/>
+            <a:ext cx="2430127" cy="420624"/>
           </a:xfrm>
           <a:prstGeom prst="roundRect">
             <a:avLst/>
           </a:prstGeom>
           <a:solidFill>
-            <a:srgbClr val="9EB0C3"/>
+            <a:srgbClr val="FF9274"/>
           </a:solidFill>
           <a:ln>
             <a:noFill/>
@@ -18690,11 +18690,11 @@
             <a:r>
               <a:rPr sz="1100" b="1" i="0">
                 <a:solidFill>
-                  <a:srgbClr val="9EB0C3"/>
-                </a:solidFill>
-                <a:latin typeface="Avenir Next"/>
-              </a:rPr>
-              <a:t>50.00</a:t>
+                  <a:srgbClr val="FF9274"/>
+                </a:solidFill>
+                <a:latin typeface="Avenir Next"/>
+              </a:rPr>
+              <a:t>32.41</a:t>
             </a:r>
           </a:p>
         </p:txBody>
@@ -18736,7 +18736,7 @@
                 </a:solidFill>
                 <a:latin typeface="Avenir Next"/>
               </a:rPr>
-              <a:t>Strongest static</a:t>
+              <a:t>Sequence only</a:t>
             </a:r>
           </a:p>
         </p:txBody>
@@ -18793,13 +18793,13 @@
         <p:spPr>
           <a:xfrm>
             <a:off x="1993392" y="2953512"/>
-            <a:ext cx="2430127" cy="420624"/>
+            <a:ext cx="2401635" cy="420624"/>
           </a:xfrm>
           <a:prstGeom prst="roundRect">
             <a:avLst/>
           </a:prstGeom>
           <a:solidFill>
-            <a:srgbClr val="FF9274"/>
+            <a:srgbClr val="FFC857"/>
           </a:solidFill>
           <a:ln>
             <a:noFill/>
@@ -18860,11 +18860,11 @@
             <a:r>
               <a:rPr sz="1100" b="1" i="0">
                 <a:solidFill>
-                  <a:srgbClr val="FF9274"/>
-                </a:solidFill>
-                <a:latin typeface="Avenir Next"/>
-              </a:rPr>
-              <a:t>32.41</a:t>
+                  <a:srgbClr val="FFC857"/>
+                </a:solidFill>
+                <a:latin typeface="Avenir Next"/>
+              </a:rPr>
+              <a:t>32.03</a:t>
             </a:r>
           </a:p>
         </p:txBody>
@@ -18906,7 +18906,7 @@
                 </a:solidFill>
                 <a:latin typeface="Avenir Next"/>
               </a:rPr>
-              <a:t>Sequence only</a:t>
+              <a:t>E01 incumbent</a:t>
             </a:r>
           </a:p>
         </p:txBody>
@@ -18963,13 +18963,13 @@
         <p:spPr>
           <a:xfrm>
             <a:off x="1993392" y="3666744"/>
-            <a:ext cx="2401635" cy="420624"/>
+            <a:ext cx="1692316" cy="420624"/>
           </a:xfrm>
           <a:prstGeom prst="roundRect">
             <a:avLst/>
           </a:prstGeom>
           <a:solidFill>
-            <a:srgbClr val="FFC857"/>
+            <a:srgbClr val="73B7FF"/>
           </a:solidFill>
           <a:ln>
             <a:noFill/>
@@ -19030,11 +19030,11 @@
             <a:r>
               <a:rPr sz="1100" b="1" i="0">
                 <a:solidFill>
-                  <a:srgbClr val="FFC857"/>
-                </a:solidFill>
-                <a:latin typeface="Avenir Next"/>
-              </a:rPr>
-              <a:t>32.03</a:t>
+                  <a:srgbClr val="73B7FF"/>
+                </a:solidFill>
+                <a:latin typeface="Avenir Next"/>
+              </a:rPr>
+              <a:t>22.57</a:t>
             </a:r>
           </a:p>
         </p:txBody>
@@ -19076,7 +19076,7 @@
                 </a:solidFill>
                 <a:latin typeface="Avenir Next"/>
               </a:rPr>
-              <a:t>Selected acoustic</a:t>
+              <a:t>E16 selected</a:t>
             </a:r>
           </a:p>
         </p:txBody>
@@ -19133,7 +19133,7 @@
         <p:spPr>
           <a:xfrm>
             <a:off x="1993392" y="4379976"/>
-            <a:ext cx="1692316" cy="420624"/>
+            <a:ext cx="1638330" cy="420624"/>
           </a:xfrm>
           <a:prstGeom prst="roundRect">
             <a:avLst/>
@@ -19204,7 +19204,7 @@
                 </a:solidFill>
                 <a:latin typeface="Avenir Next"/>
               </a:rPr>
-              <a:t>22.57</a:t>
+              <a:t>21.85</a:t>
             </a:r>
           </a:p>
         </p:txBody>
@@ -19291,7 +19291,7 @@
                 </a:solidFill>
                 <a:latin typeface="Avenir Next"/>
               </a:rPr>
-              <a:t>−9.454</a:t>
+              <a:t>−0.725</a:t>
             </a:r>
           </a:p>
         </p:txBody>
@@ -19327,13 +19327,13 @@
               </a:spcAft>
             </a:pPr>
             <a:r>
-              <a:rPr sz="1000" b="1" i="0">
+              <a:rPr sz="950" b="1" i="0">
                 <a:solidFill>
                   <a:srgbClr val="F7FAFC"/>
                 </a:solidFill>
                 <a:latin typeface="Avenir Next"/>
               </a:rPr>
-              <a:t>balanced-MAE points vs sequence-only</a:t>
+              <a:t>balanced-MAE points vs previous E01 checkpoint</a:t>
             </a:r>
           </a:p>
         </p:txBody>
@@ -19375,7 +19375,7 @@
                 </a:solidFill>
                 <a:latin typeface="Avenir Next"/>
               </a:rPr>
-              <a:t>95% CI [−10.556, −8.282]</a:t>
+              <a:t>95% CI [−1.355, −0.081]</a:t>
             </a:r>
           </a:p>
         </p:txBody>
@@ -19462,7 +19462,7 @@
                 </a:solidFill>
                 <a:latin typeface="Avenir Next"/>
               </a:rPr>
-              <a:t>17.92</a:t>
+              <a:t>18.01</a:t>
             </a:r>
           </a:p>
         </p:txBody>
@@ -19591,7 +19591,7 @@
                 </a:solidFill>
                 <a:latin typeface="Avenir Next"/>
               </a:rPr>
-              <a:t>0.584</a:t>
+              <a:t>0.579</a:t>
             </a:r>
           </a:p>
         </p:txBody>
@@ -19720,7 +19720,7 @@
                 </a:solidFill>
                 <a:latin typeface="Avenir Next"/>
               </a:rPr>
-              <a:t>0.565</a:t>
+              <a:t>0.568</a:t>
             </a:r>
           </a:p>
         </p:txBody>
@@ -19849,7 +19849,7 @@
                 </a:solidFill>
                 <a:latin typeface="Avenir Next"/>
               </a:rPr>
-              <a:t>0.551</a:t>
+              <a:t>0.558</a:t>
             </a:r>
           </a:p>
         </p:txBody>
@@ -20020,7 +20020,7 @@
                 </a:solidFill>
                 <a:latin typeface="Avenir Next"/>
               </a:rPr>
-              <a:t>10,000-draw utterance-bootstrap CI: 21.42–23.80</a:t>
+              <a:t>10,000-draw utterance-bootstrap CI: 20.73–23.05</a:t>
             </a:r>
           </a:p>
         </p:txBody>
@@ -20336,7 +20336,7 @@
                 </a:solidFill>
                 <a:latin typeface="Avenir Next"/>
               </a:rPr>
-              <a:t>What I tried—and deliberately did not ship</a:t>
+              <a:t>What I tried—and what I selected</a:t>
             </a:r>
           </a:p>
         </p:txBody>
@@ -20627,7 +20627,7 @@
                 </a:solidFill>
                 <a:latin typeface="Avenir Next"/>
               </a:rPr>
-              <a:t>25.60 vs 22.57</a:t>
+              <a:t>25.60 vs E01 22.57</a:t>
             </a:r>
           </a:p>
         </p:txBody>
@@ -21347,13 +21347,13 @@
               </a:spcAft>
             </a:pPr>
             <a:r>
-              <a:rPr sz="1500" b="1" i="0">
+              <a:rPr sz="1450" b="1" i="0">
                 <a:solidFill>
                   <a:srgbClr val="F7FAFC"/>
                 </a:solidFill>
                 <a:latin typeface="Avenir Next"/>
               </a:rPr>
-              <a:t>Frozen Whisper-tiny + constrained CTC + inverse-√ weighted ordinal head</a:t>
+              <a:t>E16: Frozen Whisper-tiny + constrained CTC + alpha=0.54 ordinal head</a:t>
             </a:r>
           </a:p>
         </p:txBody>
@@ -21395,7 +21395,7 @@
                 </a:solidFill>
                 <a:latin typeface="Avenir Next"/>
               </a:rPr>
-              <a:t>The simplest controlled candidate had the best overall trade-off.</a:t>
+              <a:t>Prompt-purged OOF and the one-shot final comparison passed every gate.</a:t>
             </a:r>
           </a:p>
         </p:txBody>
@@ -21514,7 +21514,7 @@
                 </a:solidFill>
                 <a:latin typeface="Avenir Next"/>
               </a:rPr>
-              <a:t>Sources: experiments/E02-whisper-small; E05-auxiliary-labels; E06-scorer-objectives</a:t>
+              <a:t>Sources: experiments/E02; E05; E06; E16-alpha054-confirmation</a:t>
             </a:r>
           </a:p>
         </p:txBody>
@@ -22990,7 +22990,7 @@
                 </a:solidFill>
                 <a:latin typeface="Avenir Next"/>
               </a:rPr>
-              <a:t>CONTROLLED OWN-VOICE PAIR</a:t>
+              <a:t>LEGACY E01 OWN-VOICE PAIR</a:t>
             </a:r>
           </a:p>
         </p:txBody>
@@ -23758,7 +23758,7 @@
                 </a:solidFill>
                 <a:latin typeface="Avenir Next"/>
               </a:rPr>
-              <a:t>43.53%</a:t>
+              <a:t>46.77%</a:t>
             </a:r>
           </a:p>
         </p:txBody>
@@ -23800,7 +23800,7 @@
                 </a:solidFill>
                 <a:latin typeface="Avenir Next"/>
               </a:rPr>
-              <a:t>CORRECTLY SCORED BELOW 25</a:t>
+              <a:t>E16 SCORED BELOW 25</a:t>
             </a:r>
           </a:p>
         </p:txBody>
@@ -23887,7 +23887,7 @@
                 </a:solidFill>
                 <a:latin typeface="Avenir Next"/>
               </a:rPr>
-              <a:t>11.94%</a:t>
+              <a:t>10.45%</a:t>
             </a:r>
           </a:p>
         </p:txBody>
@@ -23929,7 +23929,7 @@
                 </a:solidFill>
                 <a:latin typeface="Avenir Next"/>
               </a:rPr>
-              <a:t>INCORRECTLY SCORED ≥ 75</a:t>
+              <a:t>E16 INCORRECTLY ≥ 75</a:t>
             </a:r>
           </a:p>
         </p:txBody>
@@ -24013,7 +24013,7 @@
                 </a:solidFill>
                 <a:latin typeface="Avenir Next"/>
               </a:rPr>
-              <a:t>The model reacts when accent also hurts expected-phone recognition, but can miss subtler non-American realizations that Whisper still recognizes confidently.</a:t>
+              <a:t>Historical E01 examples reacted when accent also hurt expected-phone recognition, but missed subtler non-American realizations that Whisper still recognized confidently.</a:t>
             </a:r>
           </a:p>
         </p:txBody>
@@ -24100,7 +24100,7 @@
                 </a:solidFill>
                 <a:latin typeface="Avenir Next"/>
               </a:rPr>
-              <a:t>Conclusion: marginal utterance-level pass—not a phone-level pass.</a:t>
+              <a:t>E16 raises label-0 recall, but still misses subtle errors.</a:t>
             </a:r>
           </a:p>
         </p:txBody>
@@ -24177,7 +24177,7 @@
                 </a:solidFill>
                 <a:latin typeface="Avenir Next"/>
               </a:rPr>
-              <a:t>Sources: experiments/E07-sniff-tests/SNIFF_TEST.md; E07 and E08</a:t>
+              <a:t>Sources: experiments/E07-sniff-tests/SNIFF_TEST.md; data/alpha054_confirmation/report.md</a:t>
             </a:r>
           </a:p>
         </p:txBody>

</xml_diff>